<commit_message>
Microsoft Office test files made again from new exports (option B)
the maintainer's 13 saves (Word 16.0, Excel 16.03, PowerPoint 16.0 for Mac) from the packet make.sh
prepared replace the converted ones: hello-table's report, finance and deck re-saves and edits
(and the unlocked report), and the real files' paper, lca-model and milleleaf-deck saves.
Metadata scrubbed as before (last modified by Milleleaf, Excel's folder path trimmed). Every
test file is now as its app saved it; examples/real/SOURCES.md has the new hashes and inputs.

Box: Rust tests 189 passed, 0 failed, 9 ignored; run.sh steps 1-19 exit 0 (step 14: re-saves no
change, Word and Excel edits give the same layers as LibreOffice, PowerPoint 14 matches all
certain; step 18: no PENDING); site build and checks exit 0 (88 PASS).
</commit_message>
<xml_diff>
--- a/examples/hello-table/fixtures/deck.msoffice-edited.pptx
+++ b/examples/hello-table/fixtures/deck.msoffice-edited.pptx
@@ -177,7 +177,7 @@
           </c:val>
           <c:extLst>
             <c:ext xmlns:c16="http://schemas.microsoft.com/office/drawing/2014/chart" uri="{C3380CC4-5D6E-409C-BE32-E72D297353CC}">
-              <c16:uniqueId val="{00000000-60C5-AD4B-9867-77050676AF6D}"/>
+              <c16:uniqueId val="{00000000-87F0-DD4F-B094-EFA84DFFE421}"/>
             </c:ext>
           </c:extLst>
         </c:ser>
@@ -555,10 +555,10 @@
           <a:lstStyle/>
           <a:p>
             <a:r>
-              <a:rPr lang="en-US"/>
+              <a:rPr lang="en-US" dirty="0"/>
               <a:t>Open with the headline, then hand over to Finance.</a:t>
             </a:r>
-            <a:endParaRPr/>
+            <a:endParaRPr dirty="0"/>
           </a:p>
         </p:txBody>
       </p:sp>
@@ -3363,8 +3363,8 @@
         </p:nvSpPr>
         <p:spPr>
           <a:xfrm>
-            <a:off x="914400" y="2741295"/>
-            <a:ext cx="9525000" cy="828675"/>
+            <a:off x="914400" y="2739600"/>
+            <a:ext cx="9525000" cy="828000"/>
           </a:xfrm>
           <a:prstGeom prst="rect">
             <a:avLst/>
@@ -3384,7 +3384,7 @@
               <a:buNone/>
             </a:pPr>
             <a:r>
-              <a:rPr sz="5400" b="1">
+              <a:rPr sz="5400" b="1" dirty="0">
                 <a:solidFill>
                   <a:srgbClr val="FFFFFF"/>
                 </a:solidFill>
@@ -3424,7 +3424,7 @@
               <a:buNone/>
             </a:pPr>
             <a:r>
-              <a:rPr sz="2100">
+              <a:rPr sz="2100" dirty="0">
                 <a:solidFill>
                   <a:srgbClr val="FFFFFF"/>
                 </a:solidFill>
@@ -3517,7 +3517,7 @@
           <p:nvPr>
             <p:extLst>
               <p:ext uri="{D42A27DB-BD31-4B8C-83A1-F6EECF244321}">
-                <p14:modId xmlns:p14="http://schemas.microsoft.com/office/powerpoint/2010/main" val="3021655949"/>
+                <p14:modId xmlns:p14="http://schemas.microsoft.com/office/powerpoint/2010/main" val="1394951268"/>
               </p:ext>
             </p:extLst>
           </p:nvPr>
@@ -3572,7 +3572,7 @@
                     <a:p>
                       <a:pPr algn="r"/>
                       <a:r>
-                        <a:rPr sz="1650" b="1" dirty="0">
+                        <a:rPr sz="1650" b="1">
                           <a:latin typeface="Inter"/>
                         </a:rPr>
                         <a:t>Revenue</a:t>
@@ -3595,7 +3595,7 @@
                     <a:p>
                       <a:pPr algn="l"/>
                       <a:r>
-                        <a:rPr sz="1650" dirty="0">
+                        <a:rPr sz="1650">
                           <a:latin typeface="Inter"/>
                         </a:rPr>
                         <a:t>Adelaide</a:t>
@@ -3611,7 +3611,7 @@
                     <a:p>
                       <a:pPr algn="r"/>
                       <a:r>
-                        <a:rPr sz="1650" dirty="0">
+                        <a:rPr sz="1650">
                           <a:latin typeface="Inter"/>
                         </a:rPr>
                         <a:t>$412,000</a:t>
@@ -3634,7 +3634,7 @@
                     <a:p>
                       <a:pPr algn="l"/>
                       <a:r>
-                        <a:rPr sz="1650" dirty="0">
+                        <a:rPr sz="1650">
                           <a:latin typeface="Inter"/>
                         </a:rPr>
                         <a:t>Hong Kong</a:t>
@@ -3650,10 +3650,16 @@
                     <a:p>
                       <a:pPr algn="r"/>
                       <a:r>
+                        <a:rPr sz="1650" dirty="0">
+                          <a:latin typeface="Inter"/>
+                        </a:rPr>
+                        <a:t>$</a:t>
+                      </a:r>
+                      <a:r>
                         <a:rPr lang="en-AU" sz="1650" dirty="0">
                           <a:latin typeface="Inter"/>
                         </a:rPr>
-                        <a:t>$999</a:t>
+                        <a:t>999</a:t>
                       </a:r>
                       <a:endParaRPr sz="1650" dirty="0">
                         <a:latin typeface="Inter"/>
@@ -3758,25 +3764,25 @@
               <a:buNone/>
             </a:pPr>
             <a:r>
-              <a:rPr lang="en-US" sz="1950">
+              <a:rPr lang="en-AU" sz="1950" dirty="0">
                 <a:solidFill>
                   <a:srgbClr val="1D2433"/>
                 </a:solidFill>
                 <a:latin typeface="Inter"/>
               </a:rPr>
-              <a:t>Group </a:t>
+              <a:t>Group</a:t>
             </a:r>
             <a:r>
-              <a:rPr sz="1950">
+              <a:rPr sz="1950" dirty="0">
                 <a:solidFill>
                   <a:srgbClr val="1D2433"/>
                 </a:solidFill>
                 <a:latin typeface="Inter"/>
               </a:rPr>
-              <a:t>revenue: </a:t>
+              <a:t> revenue: </a:t>
             </a:r>
             <a:r>
-              <a:rPr sz="1950" b="1">
+              <a:rPr sz="1950" b="1" dirty="0">
                 <a:solidFill>
                   <a:srgbClr val="1D2433"/>
                 </a:solidFill>
@@ -3785,7 +3791,7 @@
               <a:t>$1,250,500</a:t>
             </a:r>
             <a:r>
-              <a:rPr sz="1950">
+              <a:rPr sz="1950" dirty="0">
                 <a:solidFill>
                   <a:srgbClr val="1D2433"/>
                 </a:solidFill>
@@ -3898,7 +3904,7 @@
               <a:buChar char="•"/>
             </a:pPr>
             <a:r>
-              <a:rPr sz="2100">
+              <a:rPr sz="2100" dirty="0">
                 <a:solidFill>
                   <a:srgbClr val="1D2433"/>
                 </a:solidFill>
@@ -3912,24 +3918,24 @@
               <a:buChar char="•"/>
             </a:pPr>
             <a:r>
-              <a:rPr sz="2100">
+              <a:rPr sz="2100" dirty="0">
                 <a:solidFill>
                   <a:srgbClr val="1D2433"/>
                 </a:solidFill>
                 <a:latin typeface="Inter"/>
               </a:rPr>
-              <a:t>Singapore pipeline </a:t>
+              <a:t>Singapore pipeline review</a:t>
             </a:r>
             <a:r>
-              <a:rPr lang="en-US" sz="2100">
+              <a:rPr lang="en-AU" sz="2100" dirty="0">
                 <a:solidFill>
                   <a:srgbClr val="1D2433"/>
                 </a:solidFill>
                 <a:latin typeface="Inter"/>
               </a:rPr>
-              <a:t>review (two deals)</a:t>
+              <a:t> (two deals)</a:t>
             </a:r>
-            <a:endParaRPr sz="2100">
+            <a:endParaRPr sz="2100" dirty="0">
               <a:solidFill>
                 <a:srgbClr val="1D2433"/>
               </a:solidFill>
@@ -3941,7 +3947,7 @@
               <a:buChar char="•"/>
             </a:pPr>
             <a:r>
-              <a:rPr sz="2100">
+              <a:rPr sz="2100" dirty="0">
                 <a:solidFill>
                   <a:srgbClr val="1D2433"/>
                 </a:solidFill>
@@ -3955,7 +3961,7 @@
               <a:buChar char="•"/>
             </a:pPr>
             <a:r>
-              <a:rPr sz="2100" i="1">
+              <a:rPr sz="2100" i="1" dirty="0">
                 <a:solidFill>
                   <a:srgbClr val="1D2433"/>
                 </a:solidFill>
@@ -3964,7 +3970,7 @@
               <a:t>Board decision:</a:t>
             </a:r>
             <a:r>
-              <a:rPr sz="2100">
+              <a:rPr sz="2100" dirty="0">
                 <a:solidFill>
                   <a:srgbClr val="1D2433"/>
                 </a:solidFill>
@@ -4001,10 +4007,10 @@
       </p:pic>
       <p:sp>
         <p:nvSpPr>
-          <p:cNvPr id="2" name="TextBox 1">
+          <p:cNvPr id="3" name="TextBox 2">
             <a:extLst>
               <a:ext uri="{FF2B5EF4-FFF2-40B4-BE49-F238E27FC236}">
-                <a16:creationId xmlns:a16="http://schemas.microsoft.com/office/drawing/2014/main" id="{F5DA9A06-4064-C9D7-765E-81F387301CC3}"/>
+                <a16:creationId xmlns:a16="http://schemas.microsoft.com/office/drawing/2014/main" id="{42D1D47C-BF37-AE8D-5F61-FD9F9AE468EF}"/>
               </a:ext>
             </a:extLst>
           </p:cNvPr>
@@ -4013,8 +4019,8 @@
         </p:nvSpPr>
         <p:spPr>
           <a:xfrm>
-            <a:off x="914400" y="5461000"/>
-            <a:ext cx="3810000" cy="381000"/>
+            <a:off x="762000" y="5955268"/>
+            <a:ext cx="6098058" cy="369332"/>
           </a:xfrm>
           <a:prstGeom prst="rect">
             <a:avLst/>
@@ -4022,13 +4028,13 @@
           <a:noFill/>
         </p:spPr>
         <p:txBody>
-          <a:bodyPr vert="horz" rtlCol="0">
+          <a:bodyPr wrap="square">
             <a:spAutoFit/>
           </a:bodyPr>
           <a:lstStyle/>
           <a:p>
             <a:r>
-              <a:rPr lang="en-US"/>
+              <a:rPr lang="en-US" dirty="0"/>
               <a:t>Owner: Finance</a:t>
             </a:r>
           </a:p>

</xml_diff>